<commit_message>
Reorganise test layout: tests/{unit_tests,functional_tests}
- Renamed tests/ → tests/unit_tests/
- Moved functional_tests/ → tests/functional_tests/
- Updated scripts/run_incremental_test.py paths accordingly
- Added data/mantri.db to .gitignore

Co-Authored-By: Claude Sonnet 4.6 <noreply@anthropic.com>
</commit_message>
<xml_diff>
--- a/interviews/staff_interview.pptx
+++ b/interviews/staff_interview.pptx
@@ -20,8 +20,8 @@
     <p:sldId id="265" r:id="rId11"/>
     <p:sldId id="266" r:id="rId12"/>
     <p:sldId id="267" r:id="rId13"/>
-    <p:sldId id="268" r:id="rId14"/>
-    <p:sldId id="269" r:id="rId15"/>
+    <p:sldId id="269" r:id="rId14"/>
+    <p:sldId id="268" r:id="rId15"/>
     <p:sldId id="270" r:id="rId16"/>
     <p:sldId id="271" r:id="rId17"/>
     <p:sldId id="272" r:id="rId18"/>
@@ -129,6 +129,64 @@
     </a:lvl9pPr>
   </p:defaultTextStyle>
   <p:extLst>
+    <p:ext uri="{521415D9-36F7-43E2-AB2F-B90AF26B5E84}">
+      <p14:sectionLst xmlns:p14="http://schemas.microsoft.com/office/powerpoint/2010/main">
+        <p14:section name="Introduction &amp; Background 3 min" id="{EAE3E8D2-065D-2947-9D2B-80A99AF6738B}">
+          <p14:sldIdLst>
+            <p14:sldId id="256"/>
+            <p14:sldId id="257"/>
+          </p14:sldIdLst>
+        </p14:section>
+        <p14:section name="Purpose &amp; Values 3 min" id="{96782366-3F48-2647-A0E3-2DE4F54C8AEC}">
+          <p14:sldIdLst>
+            <p14:sldId id="258"/>
+            <p14:sldId id="259"/>
+          </p14:sldIdLst>
+        </p14:section>
+        <p14:section name="UX Walkthrough 8 min" id="{4A32A60E-5262-4C41-BD2B-5BAC2365B0E9}">
+          <p14:sldIdLst>
+            <p14:sldId id="260"/>
+            <p14:sldId id="261"/>
+            <p14:sldId id="262"/>
+            <p14:sldId id="263"/>
+          </p14:sldIdLst>
+        </p14:section>
+        <p14:section name="SATA Output Walkthrough 7 min" id="{D5117117-8AC5-4A44-B60E-D845DBECDD35}">
+          <p14:sldIdLst>
+            <p14:sldId id="264"/>
+            <p14:sldId id="265"/>
+            <p14:sldId id="266"/>
+          </p14:sldIdLst>
+        </p14:section>
+        <p14:section name="Intermediate Q&amp;A 5 min" id="{BF477F90-4B26-3448-A64B-D9E4E85B8FB7}">
+          <p14:sldIdLst>
+            <p14:sldId id="267"/>
+          </p14:sldIdLst>
+        </p14:section>
+        <p14:section name="Trust Building 4 min" id="{C970E088-4AB2-CC49-A7D8-B8F9ECAB016D}">
+          <p14:sldIdLst>
+            <p14:sldId id="269"/>
+            <p14:sldId id="268"/>
+          </p14:sldIdLst>
+        </p14:section>
+        <p14:section name="Interview Questions 10 min" id="{C907A2FC-0C95-2F4F-AD76-1F05BF16D9E7}">
+          <p14:sldIdLst>
+            <p14:sldId id="270"/>
+            <p14:sldId id="271"/>
+            <p14:sldId id="272"/>
+            <p14:sldId id="273"/>
+            <p14:sldId id="274"/>
+            <p14:sldId id="275"/>
+          </p14:sldIdLst>
+        </p14:section>
+        <p14:section name="Final Q&amp;A + Conclusion 5 min" id="{232F9E82-4020-394F-AF45-9D4D383E1237}">
+          <p14:sldIdLst>
+            <p14:sldId id="276"/>
+            <p14:sldId id="277"/>
+          </p14:sldIdLst>
+        </p14:section>
+      </p14:sectionLst>
+    </p:ext>
     <p:ext uri="{EFAFB233-063F-42B5-8137-9DF3F51BA10A}">
       <p15:sldGuideLst xmlns:p15="http://schemas.microsoft.com/office/powerpoint/2012/main">
         <p15:guide id="1" orient="horz" pos="2160">
@@ -229,7 +287,7 @@
           <a:p>
             <a:fld id="{6646BA3E-771D-F84A-924D-2F31FCD247DA}" type="datetimeFigureOut">
               <a:rPr lang="en-US" smtClean="0"/>
-              <a:t>3/26/26</a:t>
+              <a:t>3/27/26</a:t>
             </a:fld>
             <a:endParaRPr lang="en-US"/>
           </a:p>
@@ -521,7 +579,7 @@
             <a:spLocks noGrp="1" noRot="1" noChangeAspect="1"/>
           </p:cNvSpPr>
           <p:nvPr>
-            <p:ph type="sldImg" idx="2"/>
+            <p:ph type="sldImg"/>
           </p:nvPr>
         </p:nvSpPr>
         <p:spPr/>
@@ -533,7 +591,7 @@
             <a:spLocks noGrp="1"/>
           </p:cNvSpPr>
           <p:nvPr>
-            <p:ph type="body" sz="quarter" idx="3"/>
+            <p:ph type="body" idx="1"/>
           </p:nvPr>
         </p:nvSpPr>
         <p:spPr/>
@@ -542,48 +600,46 @@
           <a:lstStyle/>
           <a:p>
             <a:r>
-              <a:t>"You all know how this business works. There are orders coming in from multiple Army clients. Suppliers to follow up with. Deliveries to coordinate. Payments to track.</a:t>
-            </a:r>
-          </a:p>
-          <a:p>
-            <a:endParaRPr/>
-          </a:p>
-          <a:p>
-            <a:r>
-              <a:t>All of this happens across many WhatsApp groups simultaneously — and Ashish is watching all of it from another city.</a:t>
-            </a:r>
-          </a:p>
-          <a:p>
-            <a:endParaRPr/>
-          </a:p>
-          <a:p>
-            <a:r>
-              <a:t>The honest truth is: when there are hundreds of messages a day across ten groups, things slip. Not because anyone isn't doing their job. But because no single person — not Ashish, not any of you — can hold all of it in their head at once.</a:t>
-            </a:r>
-          </a:p>
-          <a:p>
-            <a:endParaRPr/>
-          </a:p>
-          <a:p>
-            <a:r>
-              <a:t>That's what we're trying to solve."</a:t>
-            </a:r>
-          </a:p>
-          <a:p>
-            <a:endParaRPr/>
-          </a:p>
-          <a:p>
-            <a:r>
-              <a:t>---</a:t>
-            </a:r>
-          </a:p>
-          <a:p>
-            <a:endParaRPr/>
-          </a:p>
-          <a:p>
-            <a:r>
-              <a:t>---</a:t>
-            </a:r>
+              <a:rPr lang="en-IN" sz="1200" b="0" i="0" kern="1200" dirty="0">
+                <a:solidFill>
+                  <a:schemeClr val="tx1"/>
+                </a:solidFill>
+                <a:effectLst/>
+                <a:latin typeface="+mn-lt"/>
+                <a:ea typeface="+mn-ea"/>
+                <a:cs typeface="+mn-cs"/>
+              </a:rPr>
+              <a:t>"Namaste everyone. My name is Kunal. I'm working with Ashish on a software project called Mantri — which means assistant or advisor. I'm joining you remotely from [city] today.</a:t>
+            </a:r>
+          </a:p>
+          <a:p>
+            <a:r>
+              <a:rPr lang="en-IN" sz="1200" b="0" i="0" kern="1200" dirty="0">
+                <a:solidFill>
+                  <a:schemeClr val="tx1"/>
+                </a:solidFill>
+                <a:effectLst/>
+                <a:latin typeface="+mn-lt"/>
+                <a:ea typeface="+mn-ea"/>
+                <a:cs typeface="+mn-cs"/>
+              </a:rPr>
+              <a:t>Thank you for making the time. This session is about 45 minutes. We're going to show you what we've been building, walk through a real example, and then we really want to hear from you — your thoughts, your concerns, and your ideas.</a:t>
+            </a:r>
+          </a:p>
+          <a:p>
+            <a:r>
+              <a:rPr lang="en-IN" sz="1200" b="0" i="0" kern="1200" dirty="0">
+                <a:solidFill>
+                  <a:schemeClr val="tx1"/>
+                </a:solidFill>
+                <a:effectLst/>
+                <a:latin typeface="+mn-lt"/>
+                <a:ea typeface="+mn-ea"/>
+                <a:cs typeface="+mn-cs"/>
+              </a:rPr>
+              <a:t>Nothing here is fixed yet. Your feedback today will directly shape what gets built."</a:t>
+            </a:r>
+            <a:endParaRPr lang="en-US" dirty="0"/>
           </a:p>
         </p:txBody>
       </p:sp>
@@ -598,8 +654,24 @@
           </p:nvPr>
         </p:nvSpPr>
         <p:spPr/>
+        <p:txBody>
+          <a:bodyPr/>
+          <a:lstStyle/>
+          <a:p>
+            <a:fld id="{FD01B3FF-ABC9-8E4C-A8A7-18496BDEF743}" type="slidenum">
+              <a:rPr lang="en-US" smtClean="0"/>
+              <a:t>1</a:t>
+            </a:fld>
+            <a:endParaRPr lang="en-US"/>
+          </a:p>
+        </p:txBody>
       </p:sp>
     </p:spTree>
+    <p:extLst>
+      <p:ext uri="{BB962C8B-B14F-4D97-AF65-F5344CB8AC3E}">
+        <p14:creationId xmlns:p14="http://schemas.microsoft.com/office/powerpoint/2010/main" val="1248213613"/>
+      </p:ext>
+    </p:extLst>
   </p:cSld>
   <p:clrMapOvr>
     <a:masterClrMapping/>
@@ -652,7 +724,7 @@
           <a:lstStyle/>
           <a:p>
             <a:r>
-              <a:t>"These are five things Mantri caught from the SATA case that had not been explicitly flagged by anyone in any group.</a:t>
+              <a:t>"Here's a real task from the SATA case. The AC order for the regiment. Mantri correctly identified that the last update from the supplier was 9 days ago, that the unit is about to relocate, and that this is a high-risk situation.</a:t>
             </a:r>
           </a:p>
           <a:p>
@@ -660,7 +732,7 @@
           </a:p>
           <a:p>
             <a:r>
-              <a:t>The Amazon orders had been silent for 21 days — no one had noticed. The mini fridge size mismatch — the client asked for 75-100 litres, the supplier was delivering 45 litres. If that had reached the client unnoticed, it would have been a serious problem.</a:t>
+              <a:t>The suggested next step: call Punit directly. Not a WhatsApp message — a phone call, because the message trail has gone quiet.</a:t>
             </a:r>
           </a:p>
           <a:p>
@@ -668,7 +740,7 @@
           </a:p>
           <a:p>
             <a:r>
-              <a:t>These are the kinds of gaps that fall through in a busy operation. Mantri's job is to surface them before they become crises."</a:t>
+              <a:t>It also flagged that the delivery vehicle should not be booked until dispatch is confirmed — the sequencing is correct."</a:t>
             </a:r>
           </a:p>
           <a:p>
@@ -754,7 +826,7 @@
           <a:lstStyle/>
           <a:p>
             <a:r>
-              <a:t>"Let's pause here for questions before we go further. We've shown you what Mantri does — I'd love your first reactions.</a:t>
+              <a:t>"These are five things Mantri caught from the SATA case that had not been explicitly flagged by anyone in any group.</a:t>
             </a:r>
           </a:p>
           <a:p>
@@ -762,7 +834,7 @@
           </a:p>
           <a:p>
             <a:r>
-              <a:t>[Pause. Let responses come. Don't rush.]</a:t>
+              <a:t>The Amazon orders had been silent for 21 days — no one had noticed. The mini fridge size mismatch — the client asked for 75-100 litres, the supplier was delivering 45 litres. If that had reached the client unnoticed, it would have been a serious problem.</a:t>
             </a:r>
           </a:p>
           <a:p>
@@ -770,15 +842,7 @@
           </a:p>
           <a:p>
             <a:r>
-              <a:t>A few things worth thinking about as you respond: Does this match how orders actually flow in your work? Is there something important that happens off WhatsApp that Mantri would never see? And is there anything about this that concerns you?</a:t>
-            </a:r>
-          </a:p>
-          <a:p>
-            <a:endParaRPr/>
-          </a:p>
-          <a:p>
-            <a:r>
-              <a:t>[Take notes on responses. Acknowledge each one. If something is a valid concern, say so honestly — don't dismiss it.]"</a:t>
+              <a:t>These are the kinds of gaps that fall through in a busy operation. Mantri's job is to surface them before they become crises."</a:t>
             </a:r>
           </a:p>
           <a:p>
@@ -864,7 +928,7 @@
           <a:lstStyle/>
           <a:p>
             <a:r>
-              <a:t>"I want to be direct about something important. There are things Mantri will never do — and I want you to hear this clearly.</a:t>
+              <a:t>"Let's pause here for questions before we go further. We've shown you what Mantri does — I'd love your first reactions.</a:t>
             </a:r>
           </a:p>
           <a:p>
@@ -872,7 +936,7 @@
           </a:p>
           <a:p>
             <a:r>
-              <a:t>It will never send a message on your behalf. It will never read personal chats or any group it hasn't been explicitly given permission to access. It will never share your conversations with anyone.</a:t>
+              <a:t>[Pause. Let responses come. Don't rush.]</a:t>
             </a:r>
           </a:p>
           <a:p>
@@ -880,7 +944,7 @@
           </a:p>
           <a:p>
             <a:r>
-              <a:t>And specifically — it will not be used to evaluate staff, score performance, or report back to Ashish about who made a mistake. That is not what this is for. This is an operations tool, not a monitoring tool.</a:t>
+              <a:t>A few things worth thinking about as you respond: Does this match how orders actually flow in your work? Is there something important that happens off WhatsApp that Mantri would never see? And is there anything about this that concerns you?</a:t>
             </a:r>
           </a:p>
           <a:p>
@@ -888,7 +952,7 @@
           </a:p>
           <a:p>
             <a:r>
-              <a:t>Your WhatsApp is your workspace. Mantri is a guest in that workspace. It reads what it's invited to, does its job quietly, and stays out of everything else."</a:t>
+              <a:t>[Take notes on responses. Acknowledge each one. If something is a valid concern, say so honestly — don't dismiss it.]"</a:t>
             </a:r>
           </a:p>
           <a:p>
@@ -1076,43 +1140,46 @@
           <a:lstStyle/>
           <a:p>
             <a:r>
-              <a:rPr dirty="0"/>
-              <a:t>"Now the most important part of today. We want to hear from you directly.</a:t>
-            </a:r>
-          </a:p>
-          <a:p>
-            <a:endParaRPr dirty="0"/>
-          </a:p>
-          <a:p>
-            <a:r>
-              <a:rPr dirty="0"/>
-              <a:t>I'm going to ask a few questions. There are no right answers. If something doesn't work for you, tell me. If you think this would create more work, not less — tell me. The only way we build something useful is if you tell us the truth.</a:t>
-            </a:r>
-          </a:p>
-          <a:p>
-            <a:endParaRPr dirty="0"/>
-          </a:p>
-          <a:p>
-            <a:r>
-              <a:rPr dirty="0"/>
-              <a:t>Ashish, I'd ask you to let the team answer first for each question before you add your view — sometimes the team has a different experience than what comes through on WhatsApp."</a:t>
-            </a:r>
-          </a:p>
-          <a:p>
-            <a:endParaRPr dirty="0"/>
-          </a:p>
-          <a:p>
-            <a:r>
-              <a:rPr dirty="0"/>
+              <a:t>"I want to be direct about something important. There are things Mantri will never do — and I want you to hear this clearly.</a:t>
+            </a:r>
+          </a:p>
+          <a:p>
+            <a:endParaRPr/>
+          </a:p>
+          <a:p>
+            <a:r>
+              <a:t>It will never send a message on your behalf. It will never read personal chats or any group it hasn't been explicitly given permission to access. It will never share your conversations with anyone.</a:t>
+            </a:r>
+          </a:p>
+          <a:p>
+            <a:endParaRPr/>
+          </a:p>
+          <a:p>
+            <a:r>
+              <a:t>And specifically — it will not be used to evaluate staff, score performance, or report back to Ashish about who made a mistake. That is not what this is for. This is an operations tool, not a monitoring tool.</a:t>
+            </a:r>
+          </a:p>
+          <a:p>
+            <a:endParaRPr/>
+          </a:p>
+          <a:p>
+            <a:r>
+              <a:t>Your WhatsApp is your workspace. Mantri is a guest in that workspace. It reads what it's invited to, does its job quietly, and stays out of everything else."</a:t>
+            </a:r>
+          </a:p>
+          <a:p>
+            <a:endParaRPr/>
+          </a:p>
+          <a:p>
+            <a:r>
               <a:t>---</a:t>
             </a:r>
           </a:p>
           <a:p>
-            <a:endParaRPr dirty="0"/>
-          </a:p>
-          <a:p>
-            <a:r>
-              <a:rPr dirty="0"/>
+            <a:endParaRPr/>
+          </a:p>
+          <a:p>
+            <a:r>
               <a:t>---</a:t>
             </a:r>
           </a:p>
@@ -1183,38 +1250,43 @@
           <a:lstStyle/>
           <a:p>
             <a:r>
-              <a:t>"First question — and this is about how you work today, not about Mantri.</a:t>
-            </a:r>
-          </a:p>
-          <a:p>
-            <a:endParaRPr/>
-          </a:p>
-          <a:p>
-            <a:r>
-              <a:t>When Ashish sends you a task on WhatsApp — follow up with this supplier, arrange a delivery, confirm a rate — how do you keep track of it until it's done? Do you write it down somewhere? Pin the message? Keep it in your head?</a:t>
-            </a:r>
-          </a:p>
-          <a:p>
-            <a:endParaRPr/>
-          </a:p>
-          <a:p>
-            <a:r>
-              <a:t>[Let them answer fully. Follow up: "And what happens when there are 5 or 6 tasks at the same time?"]"</a:t>
-            </a:r>
-          </a:p>
-          <a:p>
-            <a:endParaRPr/>
-          </a:p>
-          <a:p>
-            <a:r>
+              <a:rPr dirty="0"/>
+              <a:t>"Now the most important part of today. We want to hear from you directly.</a:t>
+            </a:r>
+          </a:p>
+          <a:p>
+            <a:endParaRPr dirty="0"/>
+          </a:p>
+          <a:p>
+            <a:r>
+              <a:rPr dirty="0"/>
+              <a:t>I'm going to ask a few questions. There are no right answers. If something doesn't work for you, tell me. If you think this would create more work, not less — tell me. The only way we build something useful is if you tell us the truth.</a:t>
+            </a:r>
+          </a:p>
+          <a:p>
+            <a:endParaRPr dirty="0"/>
+          </a:p>
+          <a:p>
+            <a:r>
+              <a:rPr dirty="0"/>
+              <a:t>Ashish, I'd ask you to let the team answer first for each question before you add your view — sometimes the team has a different experience than what comes through on WhatsApp."</a:t>
+            </a:r>
+          </a:p>
+          <a:p>
+            <a:endParaRPr dirty="0"/>
+          </a:p>
+          <a:p>
+            <a:r>
+              <a:rPr dirty="0"/>
               <a:t>---</a:t>
             </a:r>
           </a:p>
           <a:p>
-            <a:endParaRPr/>
-          </a:p>
-          <a:p>
-            <a:r>
+            <a:endParaRPr dirty="0"/>
+          </a:p>
+          <a:p>
+            <a:r>
+              <a:rPr dirty="0"/>
               <a:t>---</a:t>
             </a:r>
           </a:p>
@@ -1285,7 +1357,7 @@
           <a:lstStyle/>
           <a:p>
             <a:r>
-              <a:t>"Second question. Everyone has had a moment where something slipped — a follow-up that was forgotten, a delivery that was late because someone didn't get the message. Can you think of a recent example? What happened, and what caused it?</a:t>
+              <a:t>"First question — and this is about how you work today, not about Mantri.</a:t>
             </a:r>
           </a:p>
           <a:p>
@@ -1293,7 +1365,15 @@
           </a:p>
           <a:p>
             <a:r>
-              <a:t>[This question surfaces real failure modes. Listen carefully. Don't rush past the answer. Follow up: "How often does something like that happen?", "What was the impact?"]"</a:t>
+              <a:t>When Ashish sends you a task on WhatsApp — follow up with this supplier, arrange a delivery, confirm a rate — how do you keep track of it until it's done? Do you write it down somewhere? Pin the message? Keep it in your head?</a:t>
+            </a:r>
+          </a:p>
+          <a:p>
+            <a:endParaRPr/>
+          </a:p>
+          <a:p>
+            <a:r>
+              <a:t>[Let them answer fully. Follow up: "And what happens when there are 5 or 6 tasks at the same time?"]"</a:t>
             </a:r>
           </a:p>
           <a:p>
@@ -1379,7 +1459,7 @@
           <a:lstStyle/>
           <a:p>
             <a:r>
-              <a:t>"Third question — about trust. If Mantri sent you a reminder — 'this supplier hasn't replied in 48 hours, follow up' — what would it need to look like for you to trust it and act on it? And what would make you think 'this is wrong' and ignore it?</a:t>
+              <a:t>"Second question. Everyone has had a moment where something slipped — a follow-up that was forgotten, a delivery that was late because someone didn't get the message. Can you think of a recent example? What happened, and what caused it?</a:t>
             </a:r>
           </a:p>
           <a:p>
@@ -1387,7 +1467,7 @@
           </a:p>
           <a:p>
             <a:r>
-              <a:t>[Follow up: "How many reminders a day would feel helpful? How many would feel like noise?", "Has anyone used any reminder or task tool before? What happened?"]"</a:t>
+              <a:t>[This question surfaces real failure modes. Listen carefully. Don't rush past the answer. Follow up: "How often does something like that happen?", "What was the impact?"]"</a:t>
             </a:r>
           </a:p>
           <a:p>
@@ -1473,7 +1553,7 @@
           <a:lstStyle/>
           <a:p>
             <a:r>
-              <a:t>"Fourth question — and this is really important for us to understand. Are there times when something gets resolved outside WhatsApp — a quick phone call, a conversation in person — and no one updates the group? How often does that happen?</a:t>
+              <a:t>"Third question — about trust. If Mantri sent you a reminder — 'this supplier hasn't replied in 48 hours, follow up' — what would it need to look like for you to trust it and act on it? And what would make you think 'this is wrong' and ignore it?</a:t>
             </a:r>
           </a:p>
           <a:p>
@@ -1481,7 +1561,7 @@
           </a:p>
           <a:p>
             <a:r>
-              <a:t>[This is a key question for the missing-entries risk. Don't lead them. Listen for: 'haan, Ashish calls me directly', 'sometimes I just go to the supplier', 'phone pe ho jaata hai'. Follow up: 'When that happens, does Ashish know it's been handled?']"</a:t>
+              <a:t>[Follow up: "How many reminders a day would feel helpful? How many would feel like noise?", "Has anyone used any reminder or task tool before? What happened?"]"</a:t>
             </a:r>
           </a:p>
           <a:p>
@@ -1567,7 +1647,7 @@
           <a:lstStyle/>
           <a:p>
             <a:r>
-              <a:t>"Last question — and it has two parts. First: if Mantri worked perfectly, what's the one thing you'd most want it to help you with? What would make the biggest difference in your day?</a:t>
+              <a:t>"Fourth question — and this is really important for us to understand. Are there times when something gets resolved outside WhatsApp — a quick phone call, a conversation in person — and no one updates the group? How often does that happen?</a:t>
             </a:r>
           </a:p>
           <a:p>
@@ -1575,15 +1655,7 @@
           </a:p>
           <a:p>
             <a:r>
-              <a:t>And second: is there anything you're still worried about, even after everything we've discussed today?</a:t>
-            </a:r>
-          </a:p>
-          <a:p>
-            <a:endParaRPr/>
-          </a:p>
-          <a:p>
-            <a:r>
-              <a:t>[Let every person in the room answer both parts. Don't rush. This is where the most honest feedback comes.]"</a:t>
+              <a:t>[This is a key question for the missing-entries risk. Don't lead them. Listen for: 'haan, Ashish calls me directly', 'sometimes I just go to the supplier', 'phone pe ho jaata hai'. Follow up: 'When that happens, does Ashish know it's been handled?']"</a:t>
             </a:r>
           </a:p>
           <a:p>
@@ -1669,46 +1741,52 @@
           <a:lstStyle/>
           <a:p>
             <a:r>
-              <a:t>"Mantri reads the WhatsApp groups it's given permission to read. That's all it does — it reads.</a:t>
-            </a:r>
-          </a:p>
-          <a:p>
-            <a:endParaRPr/>
-          </a:p>
-          <a:p>
-            <a:r>
-              <a:t>From those messages, it builds a task list: what orders are active, what's pending, what's at risk of being missed, and what the logical next step is for each task.</a:t>
-            </a:r>
-          </a:p>
-          <a:p>
-            <a:endParaRPr/>
-          </a:p>
-          <a:p>
-            <a:r>
-              <a:t>It does not send messages on your behalf. It does not make any decisions. It cannot write anything to WhatsApp. It only reads and summarises.</a:t>
-            </a:r>
-          </a:p>
-          <a:p>
-            <a:endParaRPr/>
-          </a:p>
-          <a:p>
-            <a:r>
-              <a:t>Think of it as a very attentive assistant sitting in the background — one that never gets tired, never loses track, and always has the full picture."</a:t>
-            </a:r>
-          </a:p>
-          <a:p>
-            <a:endParaRPr/>
-          </a:p>
-          <a:p>
-            <a:r>
+              <a:rPr dirty="0"/>
+              <a:t>"You all know how this business works. There are orders coming in from multiple Army clients. Suppliers to follow up with. Deliveries to coordinate. Payments to track.</a:t>
+            </a:r>
+          </a:p>
+          <a:p>
+            <a:endParaRPr dirty="0"/>
+          </a:p>
+          <a:p>
+            <a:r>
+              <a:rPr dirty="0"/>
+              <a:t>All of this happens across many WhatsApp groups simultaneously — and Ashish is watching all of it from another city.</a:t>
+            </a:r>
+          </a:p>
+          <a:p>
+            <a:endParaRPr dirty="0"/>
+          </a:p>
+          <a:p>
+            <a:r>
+              <a:rPr dirty="0"/>
+              <a:t>The honest truth is: when there are hundreds of messages a day across ten groups, things slip. Not because anyone isn't doing their job. But because no single person — not Ashish, not any of you — can hold all of it in their head at once.</a:t>
+            </a:r>
+          </a:p>
+          <a:p>
+            <a:endParaRPr dirty="0"/>
+          </a:p>
+          <a:p>
+            <a:r>
+              <a:rPr dirty="0"/>
+              <a:t>That's what we're trying to solve."</a:t>
+            </a:r>
+          </a:p>
+          <a:p>
+            <a:endParaRPr dirty="0"/>
+          </a:p>
+          <a:p>
+            <a:r>
+              <a:rPr dirty="0"/>
               <a:t>---</a:t>
             </a:r>
           </a:p>
           <a:p>
-            <a:endParaRPr/>
-          </a:p>
-          <a:p>
-            <a:r>
+            <a:endParaRPr dirty="0"/>
+          </a:p>
+          <a:p>
+            <a:r>
+              <a:rPr dirty="0"/>
               <a:t>---</a:t>
             </a:r>
           </a:p>
@@ -1779,7 +1857,7 @@
           <a:lstStyle/>
           <a:p>
             <a:r>
-              <a:t>"Now it's your turn to ask us anything.</a:t>
+              <a:t>"Last question — and it has two parts. First: if Mantri worked perfectly, what's the one thing you'd most want it to help you with? What would make the biggest difference in your day?</a:t>
             </a:r>
           </a:p>
           <a:p>
@@ -1787,7 +1865,7 @@
           </a:p>
           <a:p>
             <a:r>
-              <a:t>[Anticipated questions and honest answers:]</a:t>
+              <a:t>And second: is there anything you're still worried about, even after everything we've discussed today?</a:t>
             </a:r>
           </a:p>
           <a:p>
@@ -1795,31 +1873,7 @@
           </a:p>
           <a:p>
             <a:r>
-              <a:t>'How will you use what we said today?' — Everything you told us goes directly into what we build. Your concerns become our design constraints. Your suggestions become features.</a:t>
-            </a:r>
-          </a:p>
-          <a:p>
-            <a:endParaRPr/>
-          </a:p>
-          <a:p>
-            <a:r>
-              <a:t>'When will this be ready?' — We're targeting a working version by late April. You'll be among the first to try it.</a:t>
-            </a:r>
-          </a:p>
-          <a:p>
-            <a:endParaRPr/>
-          </a:p>
-          <a:p>
-            <a:r>
-              <a:t>'How do we give feedback later?' — We'll set up a simple way for you to send us feedback as you use it. Ashish will also pass on your feedback directly.</a:t>
-            </a:r>
-          </a:p>
-          <a:p>
-            <a:endParaRPr/>
-          </a:p>
-          <a:p>
-            <a:r>
-              <a:t>[Take whatever questions come. Be honest if you don't know the answer.]"</a:t>
+              <a:t>[Let every person in the room answer both parts. Don't rush. This is where the most honest feedback comes.]"</a:t>
             </a:r>
           </a:p>
           <a:p>
@@ -1905,6 +1959,132 @@
           <a:lstStyle/>
           <a:p>
             <a:r>
+              <a:t>"Now it's your turn to ask us anything.</a:t>
+            </a:r>
+          </a:p>
+          <a:p>
+            <a:endParaRPr/>
+          </a:p>
+          <a:p>
+            <a:r>
+              <a:t>[Anticipated questions and honest answers:]</a:t>
+            </a:r>
+          </a:p>
+          <a:p>
+            <a:endParaRPr/>
+          </a:p>
+          <a:p>
+            <a:r>
+              <a:t>'How will you use what we said today?' — Everything you told us goes directly into what we build. Your concerns become our design constraints. Your suggestions become features.</a:t>
+            </a:r>
+          </a:p>
+          <a:p>
+            <a:endParaRPr/>
+          </a:p>
+          <a:p>
+            <a:r>
+              <a:t>'When will this be ready?' — We're targeting a working version by late April. You'll be among the first to try it.</a:t>
+            </a:r>
+          </a:p>
+          <a:p>
+            <a:endParaRPr/>
+          </a:p>
+          <a:p>
+            <a:r>
+              <a:t>'How do we give feedback later?' — We'll set up a simple way for you to send us feedback as you use it. Ashish will also pass on your feedback directly.</a:t>
+            </a:r>
+          </a:p>
+          <a:p>
+            <a:endParaRPr/>
+          </a:p>
+          <a:p>
+            <a:r>
+              <a:t>[Take whatever questions come. Be honest if you don't know the answer.]"</a:t>
+            </a:r>
+          </a:p>
+          <a:p>
+            <a:endParaRPr/>
+          </a:p>
+          <a:p>
+            <a:r>
+              <a:t>---</a:t>
+            </a:r>
+          </a:p>
+          <a:p>
+            <a:endParaRPr/>
+          </a:p>
+          <a:p>
+            <a:r>
+              <a:t>---</a:t>
+            </a:r>
+          </a:p>
+        </p:txBody>
+      </p:sp>
+      <p:sp>
+        <p:nvSpPr>
+          <p:cNvPr id="4" name="Slide Number Placeholder 3"/>
+          <p:cNvSpPr>
+            <a:spLocks noGrp="1"/>
+          </p:cNvSpPr>
+          <p:nvPr>
+            <p:ph type="sldNum" sz="quarter" idx="5"/>
+          </p:nvPr>
+        </p:nvSpPr>
+        <p:spPr/>
+      </p:sp>
+    </p:spTree>
+  </p:cSld>
+  <p:clrMapOvr>
+    <a:masterClrMapping/>
+  </p:clrMapOvr>
+</p:notes>
+</file>
+
+<file path=ppt/notesSlides/notesSlide22.xml><?xml version="1.0" encoding="utf-8"?>
+<p:notes xmlns:a="http://schemas.openxmlformats.org/drawingml/2006/main" xmlns:r="http://schemas.openxmlformats.org/officeDocument/2006/relationships" xmlns:p="http://schemas.openxmlformats.org/presentationml/2006/main">
+  <p:cSld>
+    <p:spTree>
+      <p:nvGrpSpPr>
+        <p:cNvPr id="1" name=""/>
+        <p:cNvGrpSpPr/>
+        <p:nvPr/>
+      </p:nvGrpSpPr>
+      <p:grpSpPr>
+        <a:xfrm>
+          <a:off x="0" y="0"/>
+          <a:ext cx="0" cy="0"/>
+          <a:chOff x="0" y="0"/>
+          <a:chExt cx="0" cy="0"/>
+        </a:xfrm>
+      </p:grpSpPr>
+      <p:sp>
+        <p:nvSpPr>
+          <p:cNvPr id="2" name="Slide Image Placeholder 1"/>
+          <p:cNvSpPr>
+            <a:spLocks noGrp="1" noRot="1" noChangeAspect="1"/>
+          </p:cNvSpPr>
+          <p:nvPr>
+            <p:ph type="sldImg" idx="2"/>
+          </p:nvPr>
+        </p:nvSpPr>
+        <p:spPr/>
+      </p:sp>
+      <p:sp>
+        <p:nvSpPr>
+          <p:cNvPr id="3" name="Notes Placeholder 2"/>
+          <p:cNvSpPr>
+            <a:spLocks noGrp="1"/>
+          </p:cNvSpPr>
+          <p:nvPr>
+            <p:ph type="body" sz="quarter" idx="3"/>
+          </p:nvPr>
+        </p:nvSpPr>
+        <p:spPr/>
+        <p:txBody>
+          <a:bodyPr/>
+          <a:lstStyle/>
+          <a:p>
+            <a:r>
               <a:t>"Before we close, let me reflect back what I heard today.</a:t>
             </a:r>
           </a:p>
@@ -2112,61 +2292,46 @@
           <a:lstStyle/>
           <a:p>
             <a:r>
-              <a:rPr dirty="0"/>
-              <a:t>"Before we show you what it does, we want to be clear about what we stand for.</a:t>
-            </a:r>
-          </a:p>
-          <a:p>
-            <a:endParaRPr dirty="0"/>
-          </a:p>
-          <a:p>
-            <a:r>
-              <a:rPr dirty="0"/>
-              <a:t>First — privacy. Mantri only reads the groups that Ashish explicitly gives it permission to read. Your personal chats, your 1:1 conversations — none of that. A specific whitelist of groups, nothing else, ever.</a:t>
-            </a:r>
-          </a:p>
-          <a:p>
-            <a:endParaRPr dirty="0"/>
-          </a:p>
-          <a:p>
-            <a:r>
-              <a:rPr dirty="0"/>
-              <a:t>Second — minimal noise. We are not building something that sends you 50 alerts a day. The goal is a small number of genuinely useful reminders — the kind that save you from a problem, not the kind that distract you from your work.</a:t>
-            </a:r>
-          </a:p>
-          <a:p>
-            <a:endParaRPr dirty="0"/>
-          </a:p>
-          <a:p>
-            <a:r>
-              <a:rPr dirty="0"/>
-              <a:t>Third — you are always in control. If Mantri flags a task incorrectly, you can correct it. If it marks something as pending that you've already handled, you can update it. Nothing it says is final.</a:t>
-            </a:r>
-          </a:p>
-          <a:p>
-            <a:endParaRPr dirty="0"/>
-          </a:p>
-          <a:p>
-            <a:r>
-              <a:rPr dirty="0"/>
-              <a:t>And fourth — this is built with you. What you tell us today will change what we build. We're not here to tell you how to work. We're here to build something that fits how you actually work."</a:t>
-            </a:r>
-          </a:p>
-          <a:p>
-            <a:endParaRPr dirty="0"/>
-          </a:p>
-          <a:p>
-            <a:r>
-              <a:rPr dirty="0"/>
+              <a:t>"Mantri reads the WhatsApp groups it's given permission to read. That's all it does — it reads.</a:t>
+            </a:r>
+          </a:p>
+          <a:p>
+            <a:endParaRPr/>
+          </a:p>
+          <a:p>
+            <a:r>
+              <a:t>From those messages, it builds a task list: what orders are active, what's pending, what's at risk of being missed, and what the logical next step is for each task.</a:t>
+            </a:r>
+          </a:p>
+          <a:p>
+            <a:endParaRPr/>
+          </a:p>
+          <a:p>
+            <a:r>
+              <a:t>It does not send messages on your behalf. It does not make any decisions. It cannot write anything to WhatsApp. It only reads and summarises.</a:t>
+            </a:r>
+          </a:p>
+          <a:p>
+            <a:endParaRPr/>
+          </a:p>
+          <a:p>
+            <a:r>
+              <a:t>Think of it as a very attentive assistant sitting in the background — one that never gets tired, never loses track, and always has the full picture."</a:t>
+            </a:r>
+          </a:p>
+          <a:p>
+            <a:endParaRPr/>
+          </a:p>
+          <a:p>
+            <a:r>
               <a:t>---</a:t>
             </a:r>
           </a:p>
           <a:p>
-            <a:endParaRPr dirty="0"/>
-          </a:p>
-          <a:p>
-            <a:r>
-              <a:rPr dirty="0"/>
+            <a:endParaRPr/>
+          </a:p>
+          <a:p>
+            <a:r>
               <a:t>---</a:t>
             </a:r>
           </a:p>
@@ -2237,22 +2402,61 @@
           <a:lstStyle/>
           <a:p>
             <a:r>
-              <a:t>"Here's how it works step by step. Mantri reads the permitted WhatsApp groups — the actual messages, in Hinglish, just as you write them. It understands the context — who is talking to whom, what order is being discussed, what has been promised and by when."</a:t>
-            </a:r>
-          </a:p>
-          <a:p>
-            <a:endParaRPr/>
-          </a:p>
-          <a:p>
-            <a:r>
+              <a:rPr dirty="0"/>
+              <a:t>"Before we show you what it does, we want to be clear about what we stand for.</a:t>
+            </a:r>
+          </a:p>
+          <a:p>
+            <a:endParaRPr dirty="0"/>
+          </a:p>
+          <a:p>
+            <a:r>
+              <a:rPr dirty="0"/>
+              <a:t>First — privacy. Mantri only reads the groups that Ashish explicitly gives it permission to read. Your personal chats, your 1:1 conversations — none of that. A specific whitelist of groups, nothing else, ever.</a:t>
+            </a:r>
+          </a:p>
+          <a:p>
+            <a:endParaRPr dirty="0"/>
+          </a:p>
+          <a:p>
+            <a:r>
+              <a:rPr dirty="0"/>
+              <a:t>Second — minimal noise. We are not building something that sends you 50 alerts a day. The goal is a small number of genuinely useful reminders — the kind that save you from a problem, not the kind that distract you from your work.</a:t>
+            </a:r>
+          </a:p>
+          <a:p>
+            <a:endParaRPr dirty="0"/>
+          </a:p>
+          <a:p>
+            <a:r>
+              <a:rPr dirty="0"/>
+              <a:t>Third — you are always in control. If Mantri flags a task incorrectly, you can correct it. If it marks something as pending that you've already handled, you can update it. Nothing it says is final.</a:t>
+            </a:r>
+          </a:p>
+          <a:p>
+            <a:endParaRPr dirty="0"/>
+          </a:p>
+          <a:p>
+            <a:r>
+              <a:rPr dirty="0"/>
+              <a:t>And fourth — this is built with you. What you tell us today will change what we build. We're not here to tell you how to work. We're here to build something that fits how you actually work."</a:t>
+            </a:r>
+          </a:p>
+          <a:p>
+            <a:endParaRPr dirty="0"/>
+          </a:p>
+          <a:p>
+            <a:r>
+              <a:rPr dirty="0"/>
               <a:t>---</a:t>
             </a:r>
           </a:p>
           <a:p>
-            <a:endParaRPr/>
-          </a:p>
-          <a:p>
-            <a:r>
+            <a:endParaRPr dirty="0"/>
+          </a:p>
+          <a:p>
+            <a:r>
+              <a:rPr dirty="0"/>
               <a:t>---</a:t>
             </a:r>
           </a:p>
@@ -2323,15 +2527,7 @@
           <a:lstStyle/>
           <a:p>
             <a:r>
-              <a:t>"From those messages, it builds a task card. You can see the supplier, the item, the status, the deadline, and the priority. And underneath — the specific actions that still need to happen, with a suggested next step for each one.</a:t>
-            </a:r>
-          </a:p>
-          <a:p>
-            <a:endParaRPr/>
-          </a:p>
-          <a:p>
-            <a:r>
-              <a:t>Notice that 'arrange receiving staff' — that was never explicitly discussed in any message. Mantri inferred it from the context. Someone needs to be at the delivery location. That's an implicit task it surfaces automatically."</a:t>
+              <a:t>"Here's how it works step by step. Mantri reads the permitted WhatsApp groups — the actual messages, in Hinglish, just as you write them. It understands the context — who is talking to whom, what order is being discussed, what has been promised and by when."</a:t>
             </a:r>
           </a:p>
           <a:p>
@@ -2417,34 +2613,30 @@
           <a:lstStyle/>
           <a:p>
             <a:r>
-              <a:rPr dirty="0"/>
-              <a:t>"And finally, it flags things that need attention — information that's missing, commitments that are vague, or things it's uncertain about.</a:t>
-            </a:r>
-          </a:p>
-          <a:p>
-            <a:endParaRPr dirty="0"/>
-          </a:p>
-          <a:p>
-            <a:r>
-              <a:rPr dirty="0"/>
-              <a:t>Notice the last one: 'Sharma ji and Sharma bhai — assumed same person, please confirm.' Mantri doesn't guess silently. When it's not sure, it tells you and asks for human confirmation. This is important — it's honest about what it doesn't know."</a:t>
-            </a:r>
-          </a:p>
-          <a:p>
-            <a:endParaRPr dirty="0"/>
-          </a:p>
-          <a:p>
-            <a:r>
-              <a:rPr dirty="0"/>
+              <a:t>"From those messages, it builds a task card. You can see the supplier, the item, the status, the deadline, and the priority. And underneath — the specific actions that still need to happen, with a suggested next step for each one.</a:t>
+            </a:r>
+          </a:p>
+          <a:p>
+            <a:endParaRPr/>
+          </a:p>
+          <a:p>
+            <a:r>
+              <a:t>Notice that 'arrange receiving staff' — that was never explicitly discussed in any message. Mantri inferred it from the context. Someone needs to be at the delivery location. That's an implicit task it surfaces automatically."</a:t>
+            </a:r>
+          </a:p>
+          <a:p>
+            <a:endParaRPr/>
+          </a:p>
+          <a:p>
+            <a:r>
               <a:t>---</a:t>
             </a:r>
           </a:p>
           <a:p>
-            <a:endParaRPr dirty="0"/>
-          </a:p>
-          <a:p>
-            <a:r>
-              <a:rPr dirty="0"/>
+            <a:endParaRPr/>
+          </a:p>
+          <a:p>
+            <a:r>
               <a:t>---</a:t>
             </a:r>
           </a:p>
@@ -2516,7 +2708,7 @@
           <a:p>
             <a:r>
               <a:rPr dirty="0"/>
-              <a:t>"At any point, you can update a task. Mark it done. Change the status. Correct something Mantri got wrong. It's not smarter than you — it has less context than you do. It can be wrong, and you will always be able to fix it.</a:t>
+              <a:t>"And finally, it flags things that need attention — information that's missing, commitments that are vague, or things it's uncertain about.</a:t>
             </a:r>
           </a:p>
           <a:p>
@@ -2525,7 +2717,7 @@
           <a:p>
             <a:r>
               <a:rPr dirty="0"/>
-              <a:t>Think of it like a shared whiteboard that Mantri writes on automatically. You can always erase and rewrite."</a:t>
+              <a:t>Notice the last one: 'Sharma ji and Sharma bhai — assumed same person, please confirm.' Mantri doesn't guess silently. When it's not sure, it tells you and asks for human confirmation. This is important — it's honest about what it doesn't know."</a:t>
             </a:r>
           </a:p>
           <a:p>
@@ -2614,33 +2806,16 @@
           <a:p>
             <a:r>
               <a:rPr dirty="0"/>
-              <a:t>"Let's look at a real example. We ran Mantri on a real set of WhatsApp chats from the SATA Artillery </a:t>
-            </a:r>
-            <a:r>
-              <a:rPr lang="en-US" dirty="0"/>
-              <a:t>Battery</a:t>
-            </a:r>
+              <a:t>"At any point, you can update a task. Mark it done. Change the status. Correct something Mantri got wrong. It's not smarter than you — it has less context than you do. It can be wrong, and you will always be able to fix it.</a:t>
+            </a:r>
+          </a:p>
+          <a:p>
+            <a:endParaRPr dirty="0"/>
+          </a:p>
+          <a:p>
             <a:r>
               <a:rPr dirty="0"/>
-              <a:t> order — 4 groups, 904 messages over 24 days. We also gave it the images that were shared — invoices, payment screenshots, supplier proformas.</a:t>
-            </a:r>
-          </a:p>
-          <a:p>
-            <a:endParaRPr dirty="0"/>
-          </a:p>
-          <a:p>
-            <a:r>
-              <a:rPr dirty="0"/>
-              <a:t>It identified 12 separate tasks, correctly linked messages across different groups to the same orders, flagged payments that had no matching GST bill, and surfaced items that were at risk of being missed.</a:t>
-            </a:r>
-          </a:p>
-          <a:p>
-            <a:endParaRPr dirty="0"/>
-          </a:p>
-          <a:p>
-            <a:r>
-              <a:rPr dirty="0"/>
-              <a:t>We evaluated its output and it scored 91 out of 100. We'll walk through a few highlights now."</a:t>
+              <a:t>Think of it like a shared whiteboard that Mantri writes on automatically. You can always erase and rewrite."</a:t>
             </a:r>
           </a:p>
           <a:p>
@@ -2728,38 +2903,51 @@
           <a:lstStyle/>
           <a:p>
             <a:r>
-              <a:t>"Here's a real task from the SATA case. The AC order for the regiment. Mantri correctly identified that the last update from the supplier was 9 days ago, that the unit is about to relocate, and that this is a high-risk situation.</a:t>
-            </a:r>
-          </a:p>
-          <a:p>
-            <a:endParaRPr/>
-          </a:p>
-          <a:p>
-            <a:r>
-              <a:t>The suggested next step: call Punit directly. Not a WhatsApp message — a phone call, because the message trail has gone quiet.</a:t>
-            </a:r>
-          </a:p>
-          <a:p>
-            <a:endParaRPr/>
-          </a:p>
-          <a:p>
-            <a:r>
-              <a:t>It also flagged that the delivery vehicle should not be booked until dispatch is confirmed — the sequencing is correct."</a:t>
-            </a:r>
-          </a:p>
-          <a:p>
-            <a:endParaRPr/>
-          </a:p>
-          <a:p>
-            <a:r>
+              <a:rPr dirty="0"/>
+              <a:t>"Let's look at a real example. We ran Mantri on a real set of WhatsApp chats from the SATA Artillery </a:t>
+            </a:r>
+            <a:r>
+              <a:rPr lang="en-US" dirty="0"/>
+              <a:t>Battery</a:t>
+            </a:r>
+            <a:r>
+              <a:rPr dirty="0"/>
+              <a:t> order — 4 groups, 904 messages over 24 days. We also gave it the images that were shared — invoices, payment screenshots, supplier proformas.</a:t>
+            </a:r>
+          </a:p>
+          <a:p>
+            <a:endParaRPr dirty="0"/>
+          </a:p>
+          <a:p>
+            <a:r>
+              <a:rPr dirty="0"/>
+              <a:t>It identified 12 separate tasks, correctly linked messages across different groups to the same orders, flagged payments that had no matching GST bill, and surfaced items that were at risk of being missed.</a:t>
+            </a:r>
+          </a:p>
+          <a:p>
+            <a:endParaRPr dirty="0"/>
+          </a:p>
+          <a:p>
+            <a:r>
+              <a:rPr dirty="0"/>
+              <a:t>We evaluated its output and it scored 91 out of 100. We'll walk through a few highlights now."</a:t>
+            </a:r>
+          </a:p>
+          <a:p>
+            <a:endParaRPr dirty="0"/>
+          </a:p>
+          <a:p>
+            <a:r>
+              <a:rPr dirty="0"/>
               <a:t>---</a:t>
             </a:r>
           </a:p>
           <a:p>
-            <a:endParaRPr/>
-          </a:p>
-          <a:p>
-            <a:r>
+            <a:endParaRPr dirty="0"/>
+          </a:p>
+          <a:p>
+            <a:r>
+              <a:rPr dirty="0"/>
               <a:t>---</a:t>
             </a:r>
           </a:p>
@@ -2964,7 +3152,7 @@
           <a:p>
             <a:fld id="{5BCAD085-E8A6-8845-BD4E-CB4CCA059FC4}" type="datetimeFigureOut">
               <a:rPr lang="en-US" smtClean="0"/>
-              <a:t>3/26/26</a:t>
+              <a:t>3/27/26</a:t>
             </a:fld>
             <a:endParaRPr lang="en-US"/>
           </a:p>
@@ -3132,7 +3320,7 @@
           <a:p>
             <a:fld id="{5BCAD085-E8A6-8845-BD4E-CB4CCA059FC4}" type="datetimeFigureOut">
               <a:rPr lang="en-US" smtClean="0"/>
-              <a:t>3/26/26</a:t>
+              <a:t>3/27/26</a:t>
             </a:fld>
             <a:endParaRPr lang="en-US"/>
           </a:p>
@@ -3310,7 +3498,7 @@
           <a:p>
             <a:fld id="{5BCAD085-E8A6-8845-BD4E-CB4CCA059FC4}" type="datetimeFigureOut">
               <a:rPr lang="en-US" smtClean="0"/>
-              <a:t>3/26/26</a:t>
+              <a:t>3/27/26</a:t>
             </a:fld>
             <a:endParaRPr lang="en-US"/>
           </a:p>
@@ -3478,7 +3666,7 @@
           <a:p>
             <a:fld id="{5BCAD085-E8A6-8845-BD4E-CB4CCA059FC4}" type="datetimeFigureOut">
               <a:rPr lang="en-US" smtClean="0"/>
-              <a:t>3/26/26</a:t>
+              <a:t>3/27/26</a:t>
             </a:fld>
             <a:endParaRPr lang="en-US"/>
           </a:p>
@@ -3723,7 +3911,7 @@
           <a:p>
             <a:fld id="{5BCAD085-E8A6-8845-BD4E-CB4CCA059FC4}" type="datetimeFigureOut">
               <a:rPr lang="en-US" smtClean="0"/>
-              <a:t>3/26/26</a:t>
+              <a:t>3/27/26</a:t>
             </a:fld>
             <a:endParaRPr lang="en-US"/>
           </a:p>
@@ -4008,7 +4196,7 @@
           <a:p>
             <a:fld id="{5BCAD085-E8A6-8845-BD4E-CB4CCA059FC4}" type="datetimeFigureOut">
               <a:rPr lang="en-US" smtClean="0"/>
-              <a:t>3/26/26</a:t>
+              <a:t>3/27/26</a:t>
             </a:fld>
             <a:endParaRPr lang="en-US"/>
           </a:p>
@@ -4427,7 +4615,7 @@
           <a:p>
             <a:fld id="{5BCAD085-E8A6-8845-BD4E-CB4CCA059FC4}" type="datetimeFigureOut">
               <a:rPr lang="en-US" smtClean="0"/>
-              <a:t>3/26/26</a:t>
+              <a:t>3/27/26</a:t>
             </a:fld>
             <a:endParaRPr lang="en-US"/>
           </a:p>
@@ -4544,7 +4732,7 @@
           <a:p>
             <a:fld id="{5BCAD085-E8A6-8845-BD4E-CB4CCA059FC4}" type="datetimeFigureOut">
               <a:rPr lang="en-US" smtClean="0"/>
-              <a:t>3/26/26</a:t>
+              <a:t>3/27/26</a:t>
             </a:fld>
             <a:endParaRPr lang="en-US"/>
           </a:p>
@@ -4639,7 +4827,7 @@
           <a:p>
             <a:fld id="{5BCAD085-E8A6-8845-BD4E-CB4CCA059FC4}" type="datetimeFigureOut">
               <a:rPr lang="en-US" smtClean="0"/>
-              <a:t>3/26/26</a:t>
+              <a:t>3/27/26</a:t>
             </a:fld>
             <a:endParaRPr lang="en-US"/>
           </a:p>
@@ -4914,7 +5102,7 @@
           <a:p>
             <a:fld id="{5BCAD085-E8A6-8845-BD4E-CB4CCA059FC4}" type="datetimeFigureOut">
               <a:rPr lang="en-US" smtClean="0"/>
-              <a:t>3/26/26</a:t>
+              <a:t>3/27/26</a:t>
             </a:fld>
             <a:endParaRPr lang="en-US"/>
           </a:p>
@@ -5166,7 +5354,7 @@
           <a:p>
             <a:fld id="{5BCAD085-E8A6-8845-BD4E-CB4CCA059FC4}" type="datetimeFigureOut">
               <a:rPr lang="en-US" smtClean="0"/>
-              <a:t>3/26/26</a:t>
+              <a:t>3/27/26</a:t>
             </a:fld>
             <a:endParaRPr lang="en-US"/>
           </a:p>
@@ -5377,7 +5565,7 @@
           <a:p>
             <a:fld id="{5BCAD085-E8A6-8845-BD4E-CB4CCA059FC4}" type="datetimeFigureOut">
               <a:rPr lang="en-US" smtClean="0"/>
-              <a:t>3/26/26</a:t>
+              <a:t>3/27/26</a:t>
             </a:fld>
             <a:endParaRPr lang="en-US"/>
           </a:p>
@@ -6733,7 +6921,7 @@
               </a:defRPr>
             </a:pPr>
             <a:r>
-              <a:t>13</a:t>
+              <a:t>14</a:t>
             </a:r>
           </a:p>
         </p:txBody>
@@ -6747,7 +6935,7 @@
         <p:spPr>
           <a:xfrm>
             <a:off x="914400" y="228600"/>
-            <a:ext cx="10515600" cy="822960"/>
+            <a:ext cx="4955331" cy="553998"/>
           </a:xfrm>
           <a:prstGeom prst="rect">
             <a:avLst/>
@@ -6768,8 +6956,26 @@
               </a:defRPr>
             </a:pPr>
             <a:r>
-              <a:t>TRUST: Mantri Will Never Do</a:t>
-            </a:r>
+              <a:rPr lang="en-US" dirty="0"/>
+              <a:t>So, Who</a:t>
+            </a:r>
+            <a:r>
+              <a:rPr dirty="0"/>
+              <a:t> </a:t>
+            </a:r>
+            <a:r>
+              <a:rPr lang="en-US" dirty="0"/>
+              <a:t>Is</a:t>
+            </a:r>
+            <a:r>
+              <a:rPr dirty="0"/>
+              <a:t> </a:t>
+            </a:r>
+            <a:r>
+              <a:rPr lang="en-US" dirty="0"/>
+              <a:t>Flying This Rocket?</a:t>
+            </a:r>
+            <a:endParaRPr dirty="0"/>
           </a:p>
         </p:txBody>
       </p:sp>
@@ -6853,7 +7059,7 @@
                   <a:srgbClr val="CCDDEE"/>
                 </a:solidFill>
               </a:rPr>
-              <a:t>•  Send messages on your behalf</a:t>
+              <a:t>•  You control Mantri — not the other way around.</a:t>
             </a:r>
           </a:p>
           <a:p>
@@ -6871,7 +7077,7 @@
                   <a:srgbClr val="CCDDEE"/>
                 </a:solidFill>
               </a:rPr>
-              <a:t>•  Read personal or unlisted chats</a:t>
+              <a:t>•  Mantri suggests follow-up: you say, "Already handled it."</a:t>
             </a:r>
           </a:p>
           <a:p>
@@ -6889,7 +7095,7 @@
                   <a:srgbClr val="CCDDEE"/>
                 </a:solidFill>
               </a:rPr>
-              <a:t>•  Share your conversations with anyone else</a:t>
+              <a:t>•  Mantri says pending: you update, "This client has 2 months."</a:t>
             </a:r>
           </a:p>
           <a:p>
@@ -6907,43 +7113,7 @@
                   <a:srgbClr val="CCDDEE"/>
                 </a:solidFill>
               </a:rPr>
-              <a:t>•  Make decisions without human approval</a:t>
-            </a:r>
-          </a:p>
-          <a:p>
-            <a:pPr>
-              <a:spcBef>
-                <a:spcPts val="1000"/>
-              </a:spcBef>
-              <a:spcAft>
-                <a:spcPts val="400"/>
-              </a:spcAft>
-            </a:pPr>
-            <a:r>
-              <a:rPr sz="2100" dirty="0">
-                <a:solidFill>
-                  <a:srgbClr val="CCDDEE"/>
-                </a:solidFill>
-              </a:rPr>
-              <a:t>•  Tell Ashish who made a mistake</a:t>
-            </a:r>
-          </a:p>
-          <a:p>
-            <a:pPr>
-              <a:spcBef>
-                <a:spcPts val="1000"/>
-              </a:spcBef>
-              <a:spcAft>
-                <a:spcPts val="400"/>
-              </a:spcAft>
-            </a:pPr>
-            <a:r>
-              <a:rPr sz="2100" dirty="0">
-                <a:solidFill>
-                  <a:srgbClr val="CCDDEE"/>
-                </a:solidFill>
-              </a:rPr>
-              <a:t>•  Score or rank staff performance</a:t>
+              <a:t>•  Your knowledge always overrides Mantri.</a:t>
             </a:r>
           </a:p>
         </p:txBody>
@@ -7011,7 +7181,7 @@
               </a:defRPr>
             </a:pPr>
             <a:r>
-              <a:t>14</a:t>
+              <a:t>13</a:t>
             </a:r>
           </a:p>
         </p:txBody>
@@ -7025,7 +7195,7 @@
         <p:spPr>
           <a:xfrm>
             <a:off x="914400" y="228600"/>
-            <a:ext cx="10515600" cy="822960"/>
+            <a:ext cx="4241739" cy="553998"/>
           </a:xfrm>
           <a:prstGeom prst="rect">
             <a:avLst/>
@@ -7046,7 +7216,8 @@
               </a:defRPr>
             </a:pPr>
             <a:r>
-              <a:t>Trust: You Are In Control</a:t>
+              <a:rPr dirty="0"/>
+              <a:t>TRUST: Mantri Will Never</a:t>
             </a:r>
           </a:p>
         </p:txBody>
@@ -7104,7 +7275,7 @@
         <p:spPr>
           <a:xfrm>
             <a:off x="914400" y="1325880"/>
-            <a:ext cx="10332720" cy="5212080"/>
+            <a:ext cx="10332720" cy="2929007"/>
           </a:xfrm>
           <a:prstGeom prst="rect">
             <a:avLst/>
@@ -7126,12 +7297,28 @@
               </a:spcAft>
             </a:pPr>
             <a:r>
-              <a:rPr sz="2100">
+              <a:rPr sz="2100" dirty="0">
                 <a:solidFill>
                   <a:srgbClr val="CCDDEE"/>
                 </a:solidFill>
               </a:rPr>
-              <a:t>•  You control Mantri — not the other way around.</a:t>
+              <a:t>•  </a:t>
+            </a:r>
+            <a:r>
+              <a:rPr lang="en-US" sz="2100" dirty="0">
+                <a:solidFill>
+                  <a:srgbClr val="CCDDEE"/>
+                </a:solidFill>
+              </a:rPr>
+              <a:t>Never s</a:t>
+            </a:r>
+            <a:r>
+              <a:rPr sz="2100" dirty="0">
+                <a:solidFill>
+                  <a:srgbClr val="CCDDEE"/>
+                </a:solidFill>
+              </a:rPr>
+              <a:t>end messages on your behalf</a:t>
             </a:r>
           </a:p>
           <a:p>
@@ -7144,12 +7331,28 @@
               </a:spcAft>
             </a:pPr>
             <a:r>
-              <a:rPr sz="2100">
+              <a:rPr sz="2100" dirty="0">
                 <a:solidFill>
                   <a:srgbClr val="CCDDEE"/>
                 </a:solidFill>
               </a:rPr>
-              <a:t>•  Mantri suggests follow-up: you say, "Already handled it."</a:t>
+              <a:t>•  </a:t>
+            </a:r>
+            <a:r>
+              <a:rPr lang="en-US" sz="2100" dirty="0">
+                <a:solidFill>
+                  <a:srgbClr val="CCDDEE"/>
+                </a:solidFill>
+              </a:rPr>
+              <a:t>Never </a:t>
+            </a:r>
+            <a:r>
+              <a:rPr sz="2100" dirty="0">
+                <a:solidFill>
+                  <a:srgbClr val="CCDDEE"/>
+                </a:solidFill>
+              </a:rPr>
+              <a:t>Read personal or unlisted chats</a:t>
             </a:r>
           </a:p>
           <a:p>
@@ -7162,12 +7365,28 @@
               </a:spcAft>
             </a:pPr>
             <a:r>
-              <a:rPr sz="2100">
+              <a:rPr sz="2100" dirty="0">
                 <a:solidFill>
                   <a:srgbClr val="CCDDEE"/>
                 </a:solidFill>
               </a:rPr>
-              <a:t>•  Mantri says pending: you update, "This client has 2 months."</a:t>
+              <a:t>•  </a:t>
+            </a:r>
+            <a:r>
+              <a:rPr lang="en-US" sz="2100" dirty="0">
+                <a:solidFill>
+                  <a:srgbClr val="CCDDEE"/>
+                </a:solidFill>
+              </a:rPr>
+              <a:t>Never </a:t>
+            </a:r>
+            <a:r>
+              <a:rPr sz="2100" dirty="0">
+                <a:solidFill>
+                  <a:srgbClr val="CCDDEE"/>
+                </a:solidFill>
+              </a:rPr>
+              <a:t>Share your conversations with anyone else</a:t>
             </a:r>
           </a:p>
           <a:p>
@@ -7180,12 +7399,96 @@
               </a:spcAft>
             </a:pPr>
             <a:r>
-              <a:rPr sz="2100">
+              <a:rPr sz="2100" dirty="0">
                 <a:solidFill>
                   <a:srgbClr val="CCDDEE"/>
                 </a:solidFill>
               </a:rPr>
-              <a:t>•  Your knowledge always overrides Mantri.</a:t>
+              <a:t>•  </a:t>
+            </a:r>
+            <a:r>
+              <a:rPr lang="en-US" sz="2100" dirty="0">
+                <a:solidFill>
+                  <a:srgbClr val="CCDDEE"/>
+                </a:solidFill>
+              </a:rPr>
+              <a:t>Never </a:t>
+            </a:r>
+            <a:r>
+              <a:rPr sz="2100" dirty="0">
+                <a:solidFill>
+                  <a:srgbClr val="CCDDEE"/>
+                </a:solidFill>
+              </a:rPr>
+              <a:t>Make decisions without human approval</a:t>
+            </a:r>
+          </a:p>
+          <a:p>
+            <a:pPr>
+              <a:spcBef>
+                <a:spcPts val="1000"/>
+              </a:spcBef>
+              <a:spcAft>
+                <a:spcPts val="400"/>
+              </a:spcAft>
+            </a:pPr>
+            <a:r>
+              <a:rPr sz="2100" dirty="0">
+                <a:solidFill>
+                  <a:srgbClr val="CCDDEE"/>
+                </a:solidFill>
+              </a:rPr>
+              <a:t>•  </a:t>
+            </a:r>
+            <a:r>
+              <a:rPr lang="en-US" sz="2100" dirty="0">
+                <a:solidFill>
+                  <a:srgbClr val="CCDDEE"/>
+                </a:solidFill>
+              </a:rPr>
+              <a:t>Never </a:t>
+            </a:r>
+            <a:r>
+              <a:rPr sz="2100" dirty="0">
+                <a:solidFill>
+                  <a:srgbClr val="CCDDEE"/>
+                </a:solidFill>
+              </a:rPr>
+              <a:t>Tell Ashish who made a mistake</a:t>
+            </a:r>
+          </a:p>
+          <a:p>
+            <a:pPr>
+              <a:spcBef>
+                <a:spcPts val="1000"/>
+              </a:spcBef>
+              <a:spcAft>
+                <a:spcPts val="400"/>
+              </a:spcAft>
+            </a:pPr>
+            <a:r>
+              <a:rPr sz="2100" dirty="0">
+                <a:solidFill>
+                  <a:srgbClr val="CCDDEE"/>
+                </a:solidFill>
+              </a:rPr>
+              <a:t>•  </a:t>
+            </a:r>
+            <a:r>
+              <a:rPr lang="en-US" sz="2100" dirty="0">
+                <a:solidFill>
+                  <a:srgbClr val="CCDDEE"/>
+                </a:solidFill>
+              </a:rPr>
+              <a:t>Never </a:t>
+            </a:r>
+            <a:r>
+              <a:rPr sz="2100" dirty="0">
+                <a:solidFill>
+                  <a:srgbClr val="CCDDEE"/>
+                </a:solidFill>
+              </a:rPr>
+              <a:t>Score or rank staff performance</a:t>
             </a:r>
           </a:p>
         </p:txBody>
@@ -7368,7 +7671,7 @@
               </a:spcAft>
             </a:pPr>
             <a:r>
-              <a:rPr sz="2100">
+              <a:rPr sz="2100" dirty="0">
                 <a:solidFill>
                   <a:srgbClr val="CCDDEE"/>
                 </a:solidFill>
@@ -7386,7 +7689,7 @@
               </a:spcAft>
             </a:pPr>
             <a:r>
-              <a:rPr sz="2100">
+              <a:rPr sz="2100" dirty="0">
                 <a:solidFill>
                   <a:srgbClr val="CCDDEE"/>
                 </a:solidFill>
@@ -7404,7 +7707,7 @@
               </a:spcAft>
             </a:pPr>
             <a:r>
-              <a:rPr sz="2100">
+              <a:rPr sz="2100" dirty="0">
                 <a:solidFill>
                   <a:srgbClr val="CCDDEE"/>
                 </a:solidFill>
@@ -7422,7 +7725,7 @@
               </a:spcAft>
             </a:pPr>
             <a:r>
-              <a:rPr sz="2100">
+              <a:rPr sz="2100" dirty="0">
                 <a:solidFill>
                   <a:srgbClr val="CCDDEE"/>
                 </a:solidFill>
@@ -7588,7 +7891,7 @@
         <p:spPr>
           <a:xfrm>
             <a:off x="914400" y="1325880"/>
-            <a:ext cx="10332720" cy="5212080"/>
+            <a:ext cx="10332720" cy="918200"/>
           </a:xfrm>
           <a:prstGeom prst="rect">
             <a:avLst/>
@@ -7610,12 +7913,43 @@
               </a:spcAft>
             </a:pPr>
             <a:r>
-              <a:rPr sz="2100">
+              <a:rPr sz="2100" dirty="0">
                 <a:solidFill>
                   <a:srgbClr val="CCDDEE"/>
                 </a:solidFill>
               </a:rPr>
-              <a:t>•  When Ashish gives you a task on WhatsApp — how do you currently keep track of it until it's done?</a:t>
+              <a:t>•  When Ashish gives you a task on WhatsApp —</a:t>
+            </a:r>
+            <a:endParaRPr lang="en-US" sz="2100" dirty="0">
+              <a:solidFill>
+                <a:srgbClr val="CCDDEE"/>
+              </a:solidFill>
+            </a:endParaRPr>
+          </a:p>
+          <a:p>
+            <a:pPr>
+              <a:spcBef>
+                <a:spcPts val="1000"/>
+              </a:spcBef>
+              <a:spcAft>
+                <a:spcPts val="400"/>
+              </a:spcAft>
+            </a:pPr>
+            <a:r>
+              <a:rPr lang="en-IN" sz="2100" dirty="0">
+                <a:solidFill>
+                  <a:srgbClr val="CCDDEE"/>
+                </a:solidFill>
+              </a:rPr>
+              <a:t>    </a:t>
+            </a:r>
+            <a:r>
+              <a:rPr sz="2100" dirty="0">
+                <a:solidFill>
+                  <a:srgbClr val="CCDDEE"/>
+                </a:solidFill>
+              </a:rPr>
+              <a:t>how do you currently keep track of it until it's done?</a:t>
             </a:r>
           </a:p>
         </p:txBody>
@@ -7921,7 +8255,7 @@
         <p:spPr>
           <a:xfrm>
             <a:off x="914400" y="228600"/>
-            <a:ext cx="10515600" cy="822960"/>
+            <a:ext cx="3533531" cy="553998"/>
           </a:xfrm>
           <a:prstGeom prst="rect">
             <a:avLst/>
@@ -7942,7 +8276,12 @@
               </a:defRPr>
             </a:pPr>
             <a:r>
-              <a:t>INTERVIEW QUESTION 3</a:t>
+              <a:rPr lang="en-IN" dirty="0"/>
+              <a:t>Interview Question </a:t>
+            </a:r>
+            <a:r>
+              <a:rPr dirty="0"/>
+              <a:t>3</a:t>
             </a:r>
           </a:p>
         </p:txBody>
@@ -8000,7 +8339,7 @@
         <p:spPr>
           <a:xfrm>
             <a:off x="914400" y="1325880"/>
-            <a:ext cx="10332720" cy="5212080"/>
+            <a:ext cx="10332720" cy="918200"/>
           </a:xfrm>
           <a:prstGeom prst="rect">
             <a:avLst/>
@@ -8022,12 +8361,43 @@
               </a:spcAft>
             </a:pPr>
             <a:r>
-              <a:rPr sz="2100">
+              <a:rPr sz="2100" dirty="0">
                 <a:solidFill>
                   <a:srgbClr val="CCDDEE"/>
                 </a:solidFill>
               </a:rPr>
-              <a:t>•  If Mantri sent you a reminder about a task — what would make you trust it enough to act on it? What would make you ignore it?</a:t>
+              <a:t>•  If Mantri sent you a reminder about a task —</a:t>
+            </a:r>
+            <a:endParaRPr lang="en-US" sz="2100" dirty="0">
+              <a:solidFill>
+                <a:srgbClr val="CCDDEE"/>
+              </a:solidFill>
+            </a:endParaRPr>
+          </a:p>
+          <a:p>
+            <a:pPr>
+              <a:spcBef>
+                <a:spcPts val="1000"/>
+              </a:spcBef>
+              <a:spcAft>
+                <a:spcPts val="400"/>
+              </a:spcAft>
+            </a:pPr>
+            <a:r>
+              <a:rPr lang="en-US" sz="2100" dirty="0">
+                <a:solidFill>
+                  <a:srgbClr val="CCDDEE"/>
+                </a:solidFill>
+              </a:rPr>
+              <a:t>    </a:t>
+            </a:r>
+            <a:r>
+              <a:rPr sz="2100" dirty="0">
+                <a:solidFill>
+                  <a:srgbClr val="CCDDEE"/>
+                </a:solidFill>
+              </a:rPr>
+              <a:t>what would make you trust it enough to act on it? What would make you ignore it?</a:t>
             </a:r>
           </a:p>
         </p:txBody>
@@ -8188,7 +8558,7 @@
         <p:spPr>
           <a:xfrm>
             <a:off x="914400" y="1325880"/>
-            <a:ext cx="10332720" cy="5212080"/>
+            <a:ext cx="10332720" cy="1420902"/>
           </a:xfrm>
           <a:prstGeom prst="rect">
             <a:avLst/>
@@ -8210,12 +8580,20 @@
               </a:spcAft>
             </a:pPr>
             <a:r>
-              <a:rPr sz="2100">
+              <a:rPr sz="2100" dirty="0">
                 <a:solidFill>
                   <a:srgbClr val="CCDDEE"/>
                 </a:solidFill>
               </a:rPr>
-              <a:t>•  Are there situations where you handle something outside WhatsApp — a phone call, in person — and the group never gets updated?</a:t>
+              <a:t>•  Are there situations where you handle something outside WhatsApp</a:t>
+            </a:r>
+            <a:r>
+              <a:rPr lang="en-IN" sz="2100" dirty="0">
+                <a:solidFill>
+                  <a:srgbClr val="CCDDEE"/>
+                </a:solidFill>
+              </a:rPr>
+              <a:t> —</a:t>
             </a:r>
           </a:p>
           <a:p>
@@ -8228,7 +8606,25 @@
               </a:spcAft>
             </a:pPr>
             <a:r>
-              <a:rPr sz="2100">
+              <a:rPr lang="en-IN" sz="2100" dirty="0">
+                <a:solidFill>
+                  <a:srgbClr val="CCDDEE"/>
+                </a:solidFill>
+              </a:rPr>
+              <a:t>    and the group never gets updated?</a:t>
+            </a:r>
+          </a:p>
+          <a:p>
+            <a:pPr>
+              <a:spcBef>
+                <a:spcPts val="1000"/>
+              </a:spcBef>
+              <a:spcAft>
+                <a:spcPts val="400"/>
+              </a:spcAft>
+            </a:pPr>
+            <a:r>
+              <a:rPr sz="2100" dirty="0">
                 <a:solidFill>
                   <a:srgbClr val="CCDDEE"/>
                 </a:solidFill>
@@ -8683,6 +9079,7 @@
               </a:defRPr>
             </a:pPr>
             <a:r>
+              <a:rPr dirty="0"/>
               <a:t>Interview Question 5</a:t>
             </a:r>
           </a:p>
@@ -8741,7 +9138,7 @@
         <p:spPr>
           <a:xfrm>
             <a:off x="914400" y="1325880"/>
-            <a:ext cx="10332720" cy="5212080"/>
+            <a:ext cx="10332720" cy="918200"/>
           </a:xfrm>
           <a:prstGeom prst="rect">
             <a:avLst/>
@@ -8763,12 +9160,12 @@
               </a:spcAft>
             </a:pPr>
             <a:r>
-              <a:rPr sz="2100">
+              <a:rPr sz="2100" dirty="0">
                 <a:solidFill>
                   <a:srgbClr val="CCDDEE"/>
                 </a:solidFill>
               </a:rPr>
-              <a:t>•  Question 5</a:t>
+              <a:t>•  What one thing would Mantri help you with most?</a:t>
             </a:r>
           </a:p>
           <a:p>
@@ -8781,25 +9178,7 @@
               </a:spcAft>
             </a:pPr>
             <a:r>
-              <a:rPr sz="2100">
-                <a:solidFill>
-                  <a:srgbClr val="CCDDEE"/>
-                </a:solidFill>
-              </a:rPr>
-              <a:t>•  What one thing would Mantri help you with most?</a:t>
-            </a:r>
-          </a:p>
-          <a:p>
-            <a:pPr>
-              <a:spcBef>
-                <a:spcPts val="1000"/>
-              </a:spcBef>
-              <a:spcAft>
-                <a:spcPts val="400"/>
-              </a:spcAft>
-            </a:pPr>
-            <a:r>
-              <a:rPr sz="2100">
+              <a:rPr sz="2100" dirty="0">
                 <a:solidFill>
                   <a:srgbClr val="CCDDEE"/>
                 </a:solidFill>
@@ -8886,7 +9265,7 @@
         <p:spPr>
           <a:xfrm>
             <a:off x="914400" y="228600"/>
-            <a:ext cx="10515600" cy="822960"/>
+            <a:ext cx="1800493" cy="553998"/>
           </a:xfrm>
           <a:prstGeom prst="rect">
             <a:avLst/>
@@ -8907,7 +9286,16 @@
               </a:defRPr>
             </a:pPr>
             <a:r>
-              <a:t>FINAL Q&amp;A</a:t>
+              <a:rPr dirty="0"/>
+              <a:t>F</a:t>
+            </a:r>
+            <a:r>
+              <a:rPr lang="en-US" dirty="0"/>
+              <a:t>inal</a:t>
+            </a:r>
+            <a:r>
+              <a:rPr dirty="0"/>
+              <a:t> Q&amp;A</a:t>
             </a:r>
           </a:p>
         </p:txBody>
@@ -9146,7 +9534,7 @@
         <p:spPr>
           <a:xfrm>
             <a:off x="914400" y="228600"/>
-            <a:ext cx="10515600" cy="822960"/>
+            <a:ext cx="1925527" cy="553998"/>
           </a:xfrm>
           <a:prstGeom prst="rect">
             <a:avLst/>
@@ -9167,7 +9555,8 @@
               </a:defRPr>
             </a:pPr>
             <a:r>
-              <a:t>CONCLUSION</a:t>
+              <a:rPr lang="en-US" dirty="0"/>
+              <a:t>Conclusion</a:t>
             </a:r>
           </a:p>
         </p:txBody>

</xml_diff>